<commit_message>
made changes to the README file
</commit_message>
<xml_diff>
--- a/presentation/Florence_Kemigisha_Final_Presentation_Final.pptx
+++ b/presentation/Florence_Kemigisha_Final_Presentation_Final.pptx
@@ -4859,6 +4859,20 @@
               <a:rPr lang="en-US" dirty="0"/>
               <a:t>This Dashboard demonstrates the relationship between the current price vs Predicted price and visualizations. It has filters and it auto refreshes every 1 minute.</a:t>
             </a:r>
+          </a:p>
+          <a:p>
+            <a:endParaRPr lang="en-US" dirty="0"/>
+          </a:p>
+          <a:p>
+            <a:r>
+              <a:rPr lang="en-US" dirty="0"/>
+              <a:t>The graphs show that food prices vary by commodity, category </a:t>
+            </a:r>
+            <a:r>
+              <a:rPr lang="en-US"/>
+              <a:t>and time.</a:t>
+            </a:r>
+            <a:endParaRPr lang="en-US" dirty="0"/>
           </a:p>
         </p:txBody>
       </p:sp>

</xml_diff>